<commit_message>
feat: update all 17 flow diagram PPTs to reflect latest orchestrator build
Propagated 6 architectural facts across all generators (U1-U3, C1-C2, T1-T2,
F1-F2, A1-A2, O1-O2, I1-I2, E1-E2): explicit build_network_context() step,
SYSTEM_PROMPT + snapshot + history label, *[calling tool...]* inline marker,
JSON-sanitise + FunctionResponse + while True loop step, sync-generator
streaming step, and pure stdlib urllib / --session flag note on chat.py step.
Regenerated all 17 PPTX outputs.

Co-Authored-By: Claude Sonnet 4.6 <noreply@anthropic.com>
</commit_message>
<xml_diff>
--- a/test/A1_Query_Flow.pptx
+++ b/test/A1_Query_Flow.pptx
@@ -4342,8 +4342,9 @@
                   <a:srgbClr val="175CA6"/>
                 </a:solidFill>
               </a:rPr>
-              <a:t>prompt +
-snapshot</a:t>
+              <a:t>SYSTEM_PROMPT
++ snapshot
++ history</a:t>
             </a:r>
           </a:p>
         </p:txBody>
@@ -5835,7 +5836,7 @@
                   <a:srgbClr val="444444"/>
                 </a:solidFill>
               </a:rPr>
-              <a:t>HTTP POST {session, message} to Orchestrator /chat</a:t>
+              <a:t>HTTP POST {session_id, message} → Orchestrator /chat  (pure stdlib urllib; --session flag)</a:t>
             </a:r>
           </a:p>
         </p:txBody>
@@ -6027,7 +6028,7 @@
                   <a:srgbClr val="444444"/>
                 </a:solidFill>
               </a:rPr>
-              <a:t>Injects live network snapshot into system prompt; calls Gemini</a:t>
+              <a:t>Calls build_network_context() → GET /network; appends snapshot to SYSTEM_PROMPT; sends to Gemini</a:t>
             </a:r>
           </a:p>
         </p:txBody>
@@ -6411,7 +6412,7 @@
                   <a:srgbClr val="444444"/>
                 </a:solidFill>
               </a:rPr>
-              <a:t>Dispatches get_alerts → GET /alerts?minutes=60 on Controller</a:t>
+              <a:t>Dispatches get_alerts → queries InfluxDB directly via Flux; yields *[calling tool...]* inline</a:t>
             </a:r>
           </a:p>
         </p:txBody>
@@ -6603,7 +6604,7 @@
                   <a:srgbClr val="444444"/>
                 </a:solidFill>
               </a:rPr>
-              <a:t>Queries InfluxDB alerts measurement for last 60 min</a:t>
+              <a:t>Flux query on InfluxDB alerts measurement: last 60 min, all severities</a:t>
             </a:r>
           </a:p>
         </p:txBody>
@@ -6894,7 +6895,7 @@
             <a:avLst/>
           </a:prstGeom>
           <a:solidFill>
-            <a:srgbClr val="007E8A"/>
+            <a:srgbClr val="0A2955"/>
           </a:solidFill>
           <a:ln w="3810">
             <a:solidFill>
@@ -6953,7 +6954,7 @@
                   <a:srgbClr val="FFFFFF"/>
                 </a:solidFill>
               </a:rPr>
-              <a:t>Controller</a:t>
+              <a:t>Orchestrator</a:t>
             </a:r>
           </a:p>
         </p:txBody>
@@ -6987,7 +6988,7 @@
                   <a:srgbClr val="444444"/>
                 </a:solidFill>
               </a:rPr>
-              <a:t>Returns alert list sorted by severity and timestamp</a:t>
+              <a:t>JSON-sanitises result; appends FunctionResponse to session history; re-calls Gemini (while True loop)</a:t>
             </a:r>
           </a:p>
         </p:txBody>
@@ -7086,7 +7087,7 @@
             <a:avLst/>
           </a:prstGeom>
           <a:solidFill>
-            <a:srgbClr val="0A2955"/>
+            <a:srgbClr val="5A238C"/>
           </a:solidFill>
           <a:ln w="3810">
             <a:solidFill>
@@ -7145,7 +7146,7 @@
                   <a:srgbClr val="FFFFFF"/>
                 </a:solidFill>
               </a:rPr>
-              <a:t>Orchestrator</a:t>
+              <a:t>Gemini LLM</a:t>
             </a:r>
           </a:p>
         </p:txBody>
@@ -7179,7 +7180,7 @@
                   <a:srgbClr val="444444"/>
                 </a:solidFill>
               </a:rPr>
-              <a:t>Passes tool result to Gemini</a:t>
+              <a:t>Groups alerts by severity (CRITICAL/WARNING/INFO) and type; loop exits</a:t>
             </a:r>
           </a:p>
         </p:txBody>
@@ -7371,7 +7372,7 @@
                   <a:srgbClr val="444444"/>
                 </a:solidFill>
               </a:rPr>
-              <a:t>Groups alerts by severity (CRITICAL/WARNING/INFO) and type</a:t>
+              <a:t>Generates natural language anomaly summary</a:t>
             </a:r>
           </a:p>
         </p:txBody>
@@ -7470,7 +7471,7 @@
             <a:avLst/>
           </a:prstGeom>
           <a:solidFill>
-            <a:srgbClr val="5A238C"/>
+            <a:srgbClr val="0A2955"/>
           </a:solidFill>
           <a:ln w="3810">
             <a:solidFill>
@@ -7529,7 +7530,7 @@
                   <a:srgbClr val="FFFFFF"/>
                 </a:solidFill>
               </a:rPr>
-              <a:t>Gemini LLM</a:t>
+              <a:t>Orchestrator</a:t>
             </a:r>
           </a:p>
         </p:txBody>
@@ -7563,7 +7564,7 @@
                   <a:srgbClr val="444444"/>
                 </a:solidFill>
               </a:rPr>
-              <a:t>Generates natural language anomaly summary</a:t>
+              <a:t>Streams text/plain chunks via sync generator (StreamingResponse)</a:t>
             </a:r>
           </a:p>
         </p:txBody>
@@ -7662,198 +7663,6 @@
             <a:avLst/>
           </a:prstGeom>
           <a:solidFill>
-            <a:srgbClr val="0A2955"/>
-          </a:solidFill>
-          <a:ln w="3810">
-            <a:solidFill>
-              <a:srgbClr val="AAAAAA"/>
-            </a:solidFill>
-          </a:ln>
-        </p:spPr>
-        <p:style>
-          <a:lnRef idx="1">
-            <a:schemeClr val="accent1"/>
-          </a:lnRef>
-          <a:fillRef idx="3">
-            <a:schemeClr val="accent1"/>
-          </a:fillRef>
-          <a:effectRef idx="2">
-            <a:schemeClr val="accent1"/>
-          </a:effectRef>
-          <a:fontRef idx="minor">
-            <a:schemeClr val="lt1"/>
-          </a:fontRef>
-        </p:style>
-        <p:txBody>
-          <a:bodyPr rtlCol="0" anchor="ctr"/>
-          <a:lstStyle/>
-          <a:p>
-            <a:pPr algn="ctr"/>
-          </a:p>
-        </p:txBody>
-      </p:sp>
-      <p:sp>
-        <p:nvSpPr>
-          <p:cNvPr id="63" name="TextBox 62"/>
-          <p:cNvSpPr txBox="1"/>
-          <p:nvPr/>
-        </p:nvSpPr>
-        <p:spPr>
-          <a:xfrm>
-            <a:off x="868680" y="5404104"/>
-            <a:ext cx="1463040" cy="274320"/>
-          </a:xfrm>
-          <a:prstGeom prst="rect">
-            <a:avLst/>
-          </a:prstGeom>
-          <a:noFill/>
-        </p:spPr>
-        <p:txBody>
-          <a:bodyPr wrap="square">
-            <a:spAutoFit/>
-          </a:bodyPr>
-          <a:lstStyle/>
-          <a:p>
-            <a:pPr algn="ctr"/>
-            <a:r>
-              <a:rPr sz="900" b="1" i="0">
-                <a:solidFill>
-                  <a:srgbClr val="FFFFFF"/>
-                </a:solidFill>
-              </a:rPr>
-              <a:t>Orchestrator</a:t>
-            </a:r>
-          </a:p>
-        </p:txBody>
-      </p:sp>
-      <p:sp>
-        <p:nvSpPr>
-          <p:cNvPr id="64" name="TextBox 63"/>
-          <p:cNvSpPr txBox="1"/>
-          <p:nvPr/>
-        </p:nvSpPr>
-        <p:spPr>
-          <a:xfrm>
-            <a:off x="2423160" y="5376672"/>
-            <a:ext cx="9418320" cy="329184"/>
-          </a:xfrm>
-          <a:prstGeom prst="rect">
-            <a:avLst/>
-          </a:prstGeom>
-          <a:noFill/>
-        </p:spPr>
-        <p:txBody>
-          <a:bodyPr wrap="square">
-            <a:spAutoFit/>
-          </a:bodyPr>
-          <a:lstStyle/>
-          <a:p>
-            <a:pPr algn="l"/>
-            <a:r>
-              <a:rPr sz="1000" b="0" i="0">
-                <a:solidFill>
-                  <a:srgbClr val="444444"/>
-                </a:solidFill>
-              </a:rPr>
-              <a:t>Returns HTTP response {reply} to chat.py</a:t>
-            </a:r>
-          </a:p>
-        </p:txBody>
-      </p:sp>
-      <p:sp>
-        <p:nvSpPr>
-          <p:cNvPr id="65" name="Rectangle 64"/>
-          <p:cNvSpPr/>
-          <p:nvPr/>
-        </p:nvSpPr>
-        <p:spPr>
-          <a:xfrm>
-            <a:off x="274320" y="5742432"/>
-            <a:ext cx="11612880" cy="402336"/>
-          </a:xfrm>
-          <a:prstGeom prst="rect">
-            <a:avLst/>
-          </a:prstGeom>
-          <a:solidFill>
-            <a:srgbClr val="FFFFFF"/>
-          </a:solidFill>
-          <a:ln w="3810">
-            <a:solidFill>
-              <a:srgbClr val="CCCCCC"/>
-            </a:solidFill>
-          </a:ln>
-        </p:spPr>
-        <p:style>
-          <a:lnRef idx="1">
-            <a:schemeClr val="accent1"/>
-          </a:lnRef>
-          <a:fillRef idx="3">
-            <a:schemeClr val="accent1"/>
-          </a:fillRef>
-          <a:effectRef idx="2">
-            <a:schemeClr val="accent1"/>
-          </a:effectRef>
-          <a:fontRef idx="minor">
-            <a:schemeClr val="lt1"/>
-          </a:fontRef>
-        </p:style>
-        <p:txBody>
-          <a:bodyPr rtlCol="0" anchor="ctr"/>
-          <a:lstStyle/>
-          <a:p>
-            <a:pPr algn="ctr"/>
-          </a:p>
-        </p:txBody>
-      </p:sp>
-      <p:sp>
-        <p:nvSpPr>
-          <p:cNvPr id="66" name="TextBox 65"/>
-          <p:cNvSpPr txBox="1"/>
-          <p:nvPr/>
-        </p:nvSpPr>
-        <p:spPr>
-          <a:xfrm>
-            <a:off x="320040" y="5779008"/>
-            <a:ext cx="502920" cy="329184"/>
-          </a:xfrm>
-          <a:prstGeom prst="rect">
-            <a:avLst/>
-          </a:prstGeom>
-          <a:noFill/>
-        </p:spPr>
-        <p:txBody>
-          <a:bodyPr wrap="square">
-            <a:spAutoFit/>
-          </a:bodyPr>
-          <a:lstStyle/>
-          <a:p>
-            <a:pPr algn="ctr"/>
-            <a:r>
-              <a:rPr sz="1100" b="1" i="0">
-                <a:solidFill>
-                  <a:srgbClr val="0A2955"/>
-                </a:solidFill>
-              </a:rPr>
-              <a:t>13</a:t>
-            </a:r>
-          </a:p>
-        </p:txBody>
-      </p:sp>
-      <p:sp>
-        <p:nvSpPr>
-          <p:cNvPr id="67" name="Rectangle 66"/>
-          <p:cNvSpPr/>
-          <p:nvPr/>
-        </p:nvSpPr>
-        <p:spPr>
-          <a:xfrm>
-            <a:off x="868680" y="5806440"/>
-            <a:ext cx="1463040" cy="274320"/>
-          </a:xfrm>
-          <a:prstGeom prst="rect">
-            <a:avLst/>
-          </a:prstGeom>
-          <a:solidFill>
             <a:srgbClr val="175CA6"/>
           </a:solidFill>
           <a:ln w="3810">
@@ -7886,13 +7695,13 @@
       </p:sp>
       <p:sp>
         <p:nvSpPr>
-          <p:cNvPr id="68" name="TextBox 67"/>
+          <p:cNvPr id="63" name="TextBox 62"/>
           <p:cNvSpPr txBox="1"/>
           <p:nvPr/>
         </p:nvSpPr>
         <p:spPr>
           <a:xfrm>
-            <a:off x="868680" y="5806440"/>
+            <a:off x="868680" y="5404104"/>
             <a:ext cx="1463040" cy="274320"/>
           </a:xfrm>
           <a:prstGeom prst="rect">
@@ -7920,13 +7729,13 @@
       </p:sp>
       <p:sp>
         <p:nvSpPr>
-          <p:cNvPr id="69" name="TextBox 68"/>
+          <p:cNvPr id="64" name="TextBox 63"/>
           <p:cNvSpPr txBox="1"/>
           <p:nvPr/>
         </p:nvSpPr>
         <p:spPr>
           <a:xfrm>
-            <a:off x="2423160" y="5779008"/>
+            <a:off x="2423160" y="5376672"/>
             <a:ext cx="9418320" cy="329184"/>
           </a:xfrm>
           <a:prstGeom prst="rect">
@@ -7947,7 +7756,7 @@
                   <a:srgbClr val="444444"/>
                 </a:solidFill>
               </a:rPr>
-              <a:t>Prints anomaly report to user</a:t>
+              <a:t>Prints streamed anomaly report to operator terminal</a:t>
             </a:r>
           </a:p>
         </p:txBody>

</xml_diff>